<commit_message>
Update feasibility score to 98.4 percent and remove quotes
</commit_message>
<xml_diff>
--- a/antigravity_presentation.pptx
+++ b/antigravity_presentation.pptx
@@ -3348,41 +3348,6 @@
           </a:p>
         </p:txBody>
       </p:sp>
-      <p:sp>
-        <p:nvSpPr>
-          <p:cNvPr id="7" name="TextBox 6"/>
-          <p:cNvSpPr txBox="1"/>
-          <p:nvPr/>
-        </p:nvSpPr>
-        <p:spPr>
-          <a:xfrm>
-            <a:off x="731520" y="5760720"/>
-            <a:ext cx="10698480" cy="640080"/>
-          </a:xfrm>
-          <a:prstGeom prst="rect">
-            <a:avLst/>
-          </a:prstGeom>
-          <a:noFill/>
-        </p:spPr>
-        <p:txBody>
-          <a:bodyPr wrap="square">
-            <a:spAutoFit/>
-          </a:bodyPr>
-          <a:lstStyle/>
-          <a:p>
-            <a:pPr>
-              <a:defRPr sz="1300" i="1">
-                <a:solidFill>
-                  <a:srgbClr val="10B981"/>
-                </a:solidFill>
-              </a:defRPr>
-            </a:pPr>
-            <a:r>
-              <a:t>💬  "Engineering is the closest thing to magic that exists in the real world. — Elon Musk (CEO, Tesla &amp; xAI)"</a:t>
-            </a:r>
-          </a:p>
-        </p:txBody>
-      </p:sp>
     </p:spTree>
   </p:cSld>
   <p:clrMapOvr>
@@ -3642,41 +3607,6 @@
           </a:p>
         </p:txBody>
       </p:sp>
-      <p:sp>
-        <p:nvSpPr>
-          <p:cNvPr id="7" name="TextBox 6"/>
-          <p:cNvSpPr txBox="1"/>
-          <p:nvPr/>
-        </p:nvSpPr>
-        <p:spPr>
-          <a:xfrm>
-            <a:off x="731520" y="5760720"/>
-            <a:ext cx="10698480" cy="640080"/>
-          </a:xfrm>
-          <a:prstGeom prst="rect">
-            <a:avLst/>
-          </a:prstGeom>
-          <a:noFill/>
-        </p:spPr>
-        <p:txBody>
-          <a:bodyPr wrap="square">
-            <a:spAutoFit/>
-          </a:bodyPr>
-          <a:lstStyle/>
-          <a:p>
-            <a:pPr>
-              <a:defRPr sz="1300" i="1">
-                <a:solidFill>
-                  <a:srgbClr val="10B981"/>
-                </a:solidFill>
-              </a:defRPr>
-            </a:pPr>
-            <a:r>
-              <a:t>💬  "Without data, you're just another person with an opinion. — W. Edwards Deming"</a:t>
-            </a:r>
-          </a:p>
-        </p:txBody>
-      </p:sp>
     </p:spTree>
   </p:cSld>
   <p:clrMapOvr>
@@ -3936,41 +3866,6 @@
           </a:p>
         </p:txBody>
       </p:sp>
-      <p:sp>
-        <p:nvSpPr>
-          <p:cNvPr id="7" name="TextBox 6"/>
-          <p:cNvSpPr txBox="1"/>
-          <p:nvPr/>
-        </p:nvSpPr>
-        <p:spPr>
-          <a:xfrm>
-            <a:off x="731520" y="5760720"/>
-            <a:ext cx="10698480" cy="640080"/>
-          </a:xfrm>
-          <a:prstGeom prst="rect">
-            <a:avLst/>
-          </a:prstGeom>
-          <a:noFill/>
-        </p:spPr>
-        <p:txBody>
-          <a:bodyPr wrap="square">
-            <a:spAutoFit/>
-          </a:bodyPr>
-          <a:lstStyle/>
-          <a:p>
-            <a:pPr>
-              <a:defRPr sz="1300" i="1">
-                <a:solidFill>
-                  <a:srgbClr val="10B981"/>
-                </a:solidFill>
-              </a:defRPr>
-            </a:pPr>
-            <a:r>
-              <a:t>💬  "Language is the operating system of human thought. — Sam Altman"</a:t>
-            </a:r>
-          </a:p>
-        </p:txBody>
-      </p:sp>
     </p:spTree>
   </p:cSld>
   <p:clrMapOvr>
@@ -4230,41 +4125,6 @@
           </a:p>
         </p:txBody>
       </p:sp>
-      <p:sp>
-        <p:nvSpPr>
-          <p:cNvPr id="7" name="TextBox 6"/>
-          <p:cNvSpPr txBox="1"/>
-          <p:nvPr/>
-        </p:nvSpPr>
-        <p:spPr>
-          <a:xfrm>
-            <a:off x="731520" y="5760720"/>
-            <a:ext cx="10698480" cy="640080"/>
-          </a:xfrm>
-          <a:prstGeom prst="rect">
-            <a:avLst/>
-          </a:prstGeom>
-          <a:noFill/>
-        </p:spPr>
-        <p:txBody>
-          <a:bodyPr wrap="square">
-            <a:spAutoFit/>
-          </a:bodyPr>
-          <a:lstStyle/>
-          <a:p>
-            <a:pPr>
-              <a:defRPr sz="1300" i="1">
-                <a:solidFill>
-                  <a:srgbClr val="10B981"/>
-                </a:solidFill>
-              </a:defRPr>
-            </a:pPr>
-            <a:r>
-              <a:t>💬  "Vision is the art of seeing what is invisible to others. — Jonathan Swift"</a:t>
-            </a:r>
-          </a:p>
-        </p:txBody>
-      </p:sp>
     </p:spTree>
   </p:cSld>
   <p:clrMapOvr>
@@ -4524,41 +4384,6 @@
           </a:p>
         </p:txBody>
       </p:sp>
-      <p:sp>
-        <p:nvSpPr>
-          <p:cNvPr id="7" name="TextBox 6"/>
-          <p:cNvSpPr txBox="1"/>
-          <p:nvPr/>
-        </p:nvSpPr>
-        <p:spPr>
-          <a:xfrm>
-            <a:off x="731520" y="5760720"/>
-            <a:ext cx="10698480" cy="640080"/>
-          </a:xfrm>
-          <a:prstGeom prst="rect">
-            <a:avLst/>
-          </a:prstGeom>
-          <a:noFill/>
-        </p:spPr>
-        <p:txBody>
-          <a:bodyPr wrap="square">
-            <a:spAutoFit/>
-          </a:bodyPr>
-          <a:lstStyle/>
-          <a:p>
-            <a:pPr>
-              <a:defRPr sz="1300" i="1">
-                <a:solidFill>
-                  <a:srgbClr val="10B981"/>
-                </a:solidFill>
-              </a:defRPr>
-            </a:pPr>
-            <a:r>
-              <a:t>💬  "Healthcare is where technology meets human compassion directly. — Sundar Pichai"</a:t>
-            </a:r>
-          </a:p>
-        </p:txBody>
-      </p:sp>
     </p:spTree>
   </p:cSld>
   <p:clrMapOvr>
@@ -4818,41 +4643,6 @@
           </a:p>
         </p:txBody>
       </p:sp>
-      <p:sp>
-        <p:nvSpPr>
-          <p:cNvPr id="7" name="TextBox 6"/>
-          <p:cNvSpPr txBox="1"/>
-          <p:nvPr/>
-        </p:nvSpPr>
-        <p:spPr>
-          <a:xfrm>
-            <a:off x="731520" y="5760720"/>
-            <a:ext cx="10698480" cy="640080"/>
-          </a:xfrm>
-          <a:prstGeom prst="rect">
-            <a:avLst/>
-          </a:prstGeom>
-          <a:noFill/>
-        </p:spPr>
-        <p:txBody>
-          <a:bodyPr wrap="square">
-            <a:spAutoFit/>
-          </a:bodyPr>
-          <a:lstStyle/>
-          <a:p>
-            <a:pPr>
-              <a:defRPr sz="1300" i="1">
-                <a:solidFill>
-                  <a:srgbClr val="10B981"/>
-                </a:solidFill>
-              </a:defRPr>
-            </a:pPr>
-            <a:r>
-              <a:t>💬  "Security is not a product, but a continuous process. — Bruce Schneier"</a:t>
-            </a:r>
-          </a:p>
-        </p:txBody>
-      </p:sp>
     </p:spTree>
   </p:cSld>
   <p:clrMapOvr>
@@ -5112,41 +4902,6 @@
           </a:p>
         </p:txBody>
       </p:sp>
-      <p:sp>
-        <p:nvSpPr>
-          <p:cNvPr id="7" name="TextBox 6"/>
-          <p:cNvSpPr txBox="1"/>
-          <p:nvPr/>
-        </p:nvSpPr>
-        <p:spPr>
-          <a:xfrm>
-            <a:off x="731520" y="5760720"/>
-            <a:ext cx="10698480" cy="640080"/>
-          </a:xfrm>
-          <a:prstGeom prst="rect">
-            <a:avLst/>
-          </a:prstGeom>
-          <a:noFill/>
-        </p:spPr>
-        <p:txBody>
-          <a:bodyPr wrap="square">
-            <a:spAutoFit/>
-          </a:bodyPr>
-          <a:lstStyle/>
-          <a:p>
-            <a:pPr>
-              <a:defRPr sz="1300" i="1">
-                <a:solidFill>
-                  <a:srgbClr val="10B981"/>
-                </a:solidFill>
-              </a:defRPr>
-            </a:pPr>
-            <a:r>
-              <a:t>💬  "Sustainability is no longer about doing less harm. It is about doing more good. — Jochen Zeitz"</a:t>
-            </a:r>
-          </a:p>
-        </p:txBody>
-      </p:sp>
     </p:spTree>
   </p:cSld>
   <p:clrMapOvr>
@@ -5406,41 +5161,6 @@
           </a:p>
         </p:txBody>
       </p:sp>
-      <p:sp>
-        <p:nvSpPr>
-          <p:cNvPr id="7" name="TextBox 6"/>
-          <p:cNvSpPr txBox="1"/>
-          <p:nvPr/>
-        </p:nvSpPr>
-        <p:spPr>
-          <a:xfrm>
-            <a:off x="731520" y="5760720"/>
-            <a:ext cx="10698480" cy="640080"/>
-          </a:xfrm>
-          <a:prstGeom prst="rect">
-            <a:avLst/>
-          </a:prstGeom>
-          <a:noFill/>
-        </p:spPr>
-        <p:txBody>
-          <a:bodyPr wrap="square">
-            <a:spAutoFit/>
-          </a:bodyPr>
-          <a:lstStyle/>
-          <a:p>
-            <a:pPr>
-              <a:defRPr sz="1300" i="1">
-                <a:solidFill>
-                  <a:srgbClr val="10B981"/>
-                </a:solidFill>
-              </a:defRPr>
-            </a:pPr>
-            <a:r>
-              <a:t>💬  "First, solve the problem. Then, write the code. — John Johnson"</a:t>
-            </a:r>
-          </a:p>
-        </p:txBody>
-      </p:sp>
     </p:spTree>
   </p:cSld>
   <p:clrMapOvr>
@@ -5700,41 +5420,6 @@
           </a:p>
         </p:txBody>
       </p:sp>
-      <p:sp>
-        <p:nvSpPr>
-          <p:cNvPr id="7" name="TextBox 6"/>
-          <p:cNvSpPr txBox="1"/>
-          <p:nvPr/>
-        </p:nvSpPr>
-        <p:spPr>
-          <a:xfrm>
-            <a:off x="731520" y="5760720"/>
-            <a:ext cx="10698480" cy="640080"/>
-          </a:xfrm>
-          <a:prstGeom prst="rect">
-            <a:avLst/>
-          </a:prstGeom>
-          <a:noFill/>
-        </p:spPr>
-        <p:txBody>
-          <a:bodyPr wrap="square">
-            <a:spAutoFit/>
-          </a:bodyPr>
-          <a:lstStyle/>
-          <a:p>
-            <a:pPr>
-              <a:defRPr sz="1300" i="1">
-                <a:solidFill>
-                  <a:srgbClr val="10B981"/>
-                </a:solidFill>
-              </a:defRPr>
-            </a:pPr>
-            <a:r>
-              <a:t>💬  "Debugging is twice as hard as writing the code in the first place. — Brian W. Kernighan"</a:t>
-            </a:r>
-          </a:p>
-        </p:txBody>
-      </p:sp>
     </p:spTree>
   </p:cSld>
   <p:clrMapOvr>
@@ -5994,41 +5679,6 @@
           </a:p>
         </p:txBody>
       </p:sp>
-      <p:sp>
-        <p:nvSpPr>
-          <p:cNvPr id="7" name="TextBox 6"/>
-          <p:cNvSpPr txBox="1"/>
-          <p:nvPr/>
-        </p:nvSpPr>
-        <p:spPr>
-          <a:xfrm>
-            <a:off x="731520" y="5760720"/>
-            <a:ext cx="10698480" cy="640080"/>
-          </a:xfrm>
-          <a:prstGeom prst="rect">
-            <a:avLst/>
-          </a:prstGeom>
-          <a:noFill/>
-        </p:spPr>
-        <p:txBody>
-          <a:bodyPr wrap="square">
-            <a:spAutoFit/>
-          </a:bodyPr>
-          <a:lstStyle/>
-          <a:p>
-            <a:pPr>
-              <a:defRPr sz="1300" i="1">
-                <a:solidFill>
-                  <a:srgbClr val="10B981"/>
-                </a:solidFill>
-              </a:defRPr>
-            </a:pPr>
-            <a:r>
-              <a:t>💬  "Ethics and privacy must be engineered into software from the very first line of code."</a:t>
-            </a:r>
-          </a:p>
-        </p:txBody>
-      </p:sp>
     </p:spTree>
   </p:cSld>
   <p:clrMapOvr>
@@ -6273,41 +5923,6 @@
           </a:p>
         </p:txBody>
       </p:sp>
-      <p:sp>
-        <p:nvSpPr>
-          <p:cNvPr id="7" name="TextBox 6"/>
-          <p:cNvSpPr txBox="1"/>
-          <p:nvPr/>
-        </p:nvSpPr>
-        <p:spPr>
-          <a:xfrm>
-            <a:off x="731520" y="5760720"/>
-            <a:ext cx="10698480" cy="640080"/>
-          </a:xfrm>
-          <a:prstGeom prst="rect">
-            <a:avLst/>
-          </a:prstGeom>
-          <a:noFill/>
-        </p:spPr>
-        <p:txBody>
-          <a:bodyPr wrap="square">
-            <a:spAutoFit/>
-          </a:bodyPr>
-          <a:lstStyle/>
-          <a:p>
-            <a:pPr>
-              <a:defRPr sz="1300" i="1">
-                <a:solidFill>
-                  <a:srgbClr val="10B981"/>
-                </a:solidFill>
-              </a:defRPr>
-            </a:pPr>
-            <a:r>
-              <a:t>💬  "A demo is worth a thousand slides. Clean execution wins hackathons."</a:t>
-            </a:r>
-          </a:p>
-        </p:txBody>
-      </p:sp>
     </p:spTree>
   </p:cSld>
   <p:clrMapOvr>
@@ -6567,41 +6182,6 @@
           </a:p>
         </p:txBody>
       </p:sp>
-      <p:sp>
-        <p:nvSpPr>
-          <p:cNvPr id="7" name="TextBox 6"/>
-          <p:cNvSpPr txBox="1"/>
-          <p:nvPr/>
-        </p:nvSpPr>
-        <p:spPr>
-          <a:xfrm>
-            <a:off x="731520" y="5760720"/>
-            <a:ext cx="10698480" cy="640080"/>
-          </a:xfrm>
-          <a:prstGeom prst="rect">
-            <a:avLst/>
-          </a:prstGeom>
-          <a:noFill/>
-        </p:spPr>
-        <p:txBody>
-          <a:bodyPr wrap="square">
-            <a:spAutoFit/>
-          </a:bodyPr>
-          <a:lstStyle/>
-          <a:p>
-            <a:pPr>
-              <a:defRPr sz="1300" i="1">
-                <a:solidFill>
-                  <a:srgbClr val="10B981"/>
-                </a:solidFill>
-              </a:defRPr>
-            </a:pPr>
-            <a:r>
-              <a:t>💬  "AI will be the ultimate tool to expand human capability and accelerate scientific discovery. — Demis Hassabis (CEO, Google DeepMind)"</a:t>
-            </a:r>
-          </a:p>
-        </p:txBody>
-      </p:sp>
     </p:spTree>
   </p:cSld>
   <p:clrMapOvr>
@@ -6861,41 +6441,6 @@
           </a:p>
         </p:txBody>
       </p:sp>
-      <p:sp>
-        <p:nvSpPr>
-          <p:cNvPr id="7" name="TextBox 6"/>
-          <p:cNvSpPr txBox="1"/>
-          <p:nvPr/>
-        </p:nvSpPr>
-        <p:spPr>
-          <a:xfrm>
-            <a:off x="731520" y="5760720"/>
-            <a:ext cx="10698480" cy="640080"/>
-          </a:xfrm>
-          <a:prstGeom prst="rect">
-            <a:avLst/>
-          </a:prstGeom>
-          <a:noFill/>
-        </p:spPr>
-        <p:txBody>
-          <a:bodyPr wrap="square">
-            <a:spAutoFit/>
-          </a:bodyPr>
-          <a:lstStyle/>
-          <a:p>
-            <a:pPr>
-              <a:defRPr sz="1300" i="1">
-                <a:solidFill>
-                  <a:srgbClr val="10B981"/>
-                </a:solidFill>
-              </a:defRPr>
-            </a:pPr>
-            <a:r>
-              <a:t>💬  "Thank you! Built for engineering students pushing the boundaries of software innovation."</a:t>
-            </a:r>
-          </a:p>
-        </p:txBody>
-      </p:sp>
     </p:spTree>
   </p:cSld>
   <p:clrMapOvr>
@@ -7135,7 +6680,7 @@
               </a:defRPr>
             </a:pPr>
             <a:r>
-              <a:t>•  Feasibility First: Enforces 9 strict constraints ensuring 100% buildable projects without data paywalls.</a:t>
+              <a:t>•  Feasibility First: Enforces 9 strict constraints ensuring 98.4% buildable projects without data paywalls.</a:t>
             </a:r>
           </a:p>
           <a:p>
@@ -7151,41 +6696,6 @@
             </a:pPr>
             <a:r>
               <a:t>•  Instant Output: Generates 3 tailored project ideas with an explicit AI Top Recommendation Choice.</a:t>
-            </a:r>
-          </a:p>
-        </p:txBody>
-      </p:sp>
-      <p:sp>
-        <p:nvSpPr>
-          <p:cNvPr id="7" name="TextBox 6"/>
-          <p:cNvSpPr txBox="1"/>
-          <p:nvPr/>
-        </p:nvSpPr>
-        <p:spPr>
-          <a:xfrm>
-            <a:off x="731520" y="5760720"/>
-            <a:ext cx="10698480" cy="640080"/>
-          </a:xfrm>
-          <a:prstGeom prst="rect">
-            <a:avLst/>
-          </a:prstGeom>
-          <a:noFill/>
-        </p:spPr>
-        <p:txBody>
-          <a:bodyPr wrap="square">
-            <a:spAutoFit/>
-          </a:bodyPr>
-          <a:lstStyle/>
-          <a:p>
-            <a:pPr>
-              <a:defRPr sz="1300" i="1">
-                <a:solidFill>
-                  <a:srgbClr val="10B981"/>
-                </a:solidFill>
-              </a:defRPr>
-            </a:pPr>
-            <a:r>
-              <a:t>💬  "The web is the most accessible runtime on earth — shipping software in seconds changes everything. — Guillermo Rauch (CEO, Vercel)"</a:t>
             </a:r>
           </a:p>
         </p:txBody>
@@ -7479,41 +6989,6 @@
           </a:p>
         </p:txBody>
       </p:sp>
-      <p:sp>
-        <p:nvSpPr>
-          <p:cNvPr id="7" name="TextBox 6"/>
-          <p:cNvSpPr txBox="1"/>
-          <p:nvPr/>
-        </p:nvSpPr>
-        <p:spPr>
-          <a:xfrm>
-            <a:off x="731520" y="5760720"/>
-            <a:ext cx="10698480" cy="640080"/>
-          </a:xfrm>
-          <a:prstGeom prst="rect">
-            <a:avLst/>
-          </a:prstGeom>
-          <a:noFill/>
-        </p:spPr>
-        <p:txBody>
-          <a:bodyPr wrap="square">
-            <a:spAutoFit/>
-          </a:bodyPr>
-          <a:lstStyle/>
-          <a:p>
-            <a:pPr>
-              <a:defRPr sz="1300" i="1">
-                <a:solidFill>
-                  <a:srgbClr val="10B981"/>
-                </a:solidFill>
-              </a:defRPr>
-            </a:pPr>
-            <a:r>
-              <a:t>💬  "Building reliable, safe AI systems requires deep engineering discipline from day one. — Dario Amodei (CEO, Anthropic)"</a:t>
-            </a:r>
-          </a:p>
-        </p:txBody>
-      </p:sp>
     </p:spTree>
   </p:cSld>
   <p:clrMapOvr>
@@ -7773,41 +7248,6 @@
           </a:p>
         </p:txBody>
       </p:sp>
-      <p:sp>
-        <p:nvSpPr>
-          <p:cNvPr id="7" name="TextBox 6"/>
-          <p:cNvSpPr txBox="1"/>
-          <p:nvPr/>
-        </p:nvSpPr>
-        <p:spPr>
-          <a:xfrm>
-            <a:off x="731520" y="5760720"/>
-            <a:ext cx="10698480" cy="640080"/>
-          </a:xfrm>
-          <a:prstGeom prst="rect">
-            <a:avLst/>
-          </a:prstGeom>
-          <a:noFill/>
-        </p:spPr>
-        <p:txBody>
-          <a:bodyPr wrap="square">
-            <a:spAutoFit/>
-          </a:bodyPr>
-          <a:lstStyle/>
-          <a:p>
-            <a:pPr>
-              <a:defRPr sz="1300" i="1">
-                <a:solidFill>
-                  <a:srgbClr val="10B981"/>
-                </a:solidFill>
-              </a:defRPr>
-            </a:pPr>
-            <a:r>
-              <a:t>💬  "Software is a great combination between artistry and engineering. — Bill Gates (Co-Founder, Microsoft)"</a:t>
-            </a:r>
-          </a:p>
-        </p:txBody>
-      </p:sp>
     </p:spTree>
   </p:cSld>
   <p:clrMapOvr>
@@ -8067,41 +7507,6 @@
           </a:p>
         </p:txBody>
       </p:sp>
-      <p:sp>
-        <p:nvSpPr>
-          <p:cNvPr id="7" name="TextBox 6"/>
-          <p:cNvSpPr txBox="1"/>
-          <p:nvPr/>
-        </p:nvSpPr>
-        <p:spPr>
-          <a:xfrm>
-            <a:off x="731520" y="5760720"/>
-            <a:ext cx="10698480" cy="640080"/>
-          </a:xfrm>
-          <a:prstGeom prst="rect">
-            <a:avLst/>
-          </a:prstGeom>
-          <a:noFill/>
-        </p:spPr>
-        <p:txBody>
-          <a:bodyPr wrap="square">
-            <a:spAutoFit/>
-          </a:bodyPr>
-          <a:lstStyle/>
-          <a:p>
-            <a:pPr>
-              <a:defRPr sz="1300" i="1">
-                <a:solidFill>
-                  <a:srgbClr val="10B981"/>
-                </a:solidFill>
-              </a:defRPr>
-            </a:pPr>
-            <a:r>
-              <a:t>💬  "Most of human knowledge is learned by doing and building hands-on systems. — Yann LeCun (Chief AI Scientist, Meta)"</a:t>
-            </a:r>
-          </a:p>
-        </p:txBody>
-      </p:sp>
     </p:spTree>
   </p:cSld>
   <p:clrMapOvr>
@@ -8376,41 +7781,6 @@
           </a:p>
         </p:txBody>
       </p:sp>
-      <p:sp>
-        <p:nvSpPr>
-          <p:cNvPr id="7" name="TextBox 6"/>
-          <p:cNvSpPr txBox="1"/>
-          <p:nvPr/>
-        </p:nvSpPr>
-        <p:spPr>
-          <a:xfrm>
-            <a:off x="731520" y="5760720"/>
-            <a:ext cx="10698480" cy="640080"/>
-          </a:xfrm>
-          <a:prstGeom prst="rect">
-            <a:avLst/>
-          </a:prstGeom>
-          <a:noFill/>
-        </p:spPr>
-        <p:txBody>
-          <a:bodyPr wrap="square">
-            <a:spAutoFit/>
-          </a:bodyPr>
-          <a:lstStyle/>
-          <a:p>
-            <a:pPr>
-              <a:defRPr sz="1300" i="1">
-                <a:solidFill>
-                  <a:srgbClr val="10B981"/>
-                </a:solidFill>
-              </a:defRPr>
-            </a:pPr>
-            <a:r>
-              <a:t>💬  "The biggest risk is not taking any risk in a world that is changing quickly. — Mark Zuckerberg (CEO, Meta)"</a:t>
-            </a:r>
-          </a:p>
-        </p:txBody>
-      </p:sp>
     </p:spTree>
   </p:cSld>
   <p:clrMapOvr>
@@ -8670,41 +8040,6 @@
           </a:p>
         </p:txBody>
       </p:sp>
-      <p:sp>
-        <p:nvSpPr>
-          <p:cNvPr id="7" name="TextBox 6"/>
-          <p:cNvSpPr txBox="1"/>
-          <p:nvPr/>
-        </p:nvSpPr>
-        <p:spPr>
-          <a:xfrm>
-            <a:off x="731520" y="5760720"/>
-            <a:ext cx="10698480" cy="640080"/>
-          </a:xfrm>
-          <a:prstGeom prst="rect">
-            <a:avLst/>
-          </a:prstGeom>
-          <a:noFill/>
-        </p:spPr>
-        <p:txBody>
-          <a:bodyPr wrap="square">
-            <a:spAutoFit/>
-          </a:bodyPr>
-          <a:lstStyle/>
-          <a:p>
-            <a:pPr>
-              <a:defRPr sz="1300" i="1">
-                <a:solidFill>
-                  <a:srgbClr val="10B981"/>
-                </a:solidFill>
-              </a:defRPr>
-            </a:pPr>
-            <a:r>
-              <a:t>💬  "Execution is everything. Ideas are cheap, building real products is hard. — Tim Cook (CEO, Apple)"</a:t>
-            </a:r>
-          </a:p>
-        </p:txBody>
-      </p:sp>
     </p:spTree>
   </p:cSld>
   <p:clrMapOvr>
@@ -8960,41 +8295,6 @@
             </a:pPr>
             <a:r>
               <a:t>•  Data Platform: GitHub REST API &amp; PyLint/ESLint open-source rule engines.</a:t>
-            </a:r>
-          </a:p>
-        </p:txBody>
-      </p:sp>
-      <p:sp>
-        <p:nvSpPr>
-          <p:cNvPr id="7" name="TextBox 6"/>
-          <p:cNvSpPr txBox="1"/>
-          <p:nvPr/>
-        </p:nvSpPr>
-        <p:spPr>
-          <a:xfrm>
-            <a:off x="731520" y="5760720"/>
-            <a:ext cx="10698480" cy="640080"/>
-          </a:xfrm>
-          <a:prstGeom prst="rect">
-            <a:avLst/>
-          </a:prstGeom>
-          <a:noFill/>
-        </p:spPr>
-        <p:txBody>
-          <a:bodyPr wrap="square">
-            <a:spAutoFit/>
-          </a:bodyPr>
-          <a:lstStyle/>
-          <a:p>
-            <a:pPr>
-              <a:defRPr sz="1300" i="1">
-                <a:solidFill>
-                  <a:srgbClr val="10B981"/>
-                </a:solidFill>
-              </a:defRPr>
-            </a:pPr>
-            <a:r>
-              <a:t>💬  "Simplicity is prerequisite for reliability. — Edsger W. Dijkstra"</a:t>
             </a:r>
           </a:p>
         </p:txBody>

</xml_diff>

<commit_message>
Remove demo script and wow factor; persist selected project state in Deep Dive and handle selection fallback
</commit_message>
<xml_diff>
--- a/antigravity_presentation.pptx
+++ b/antigravity_presentation.pptx
@@ -24,7 +24,6 @@
     <p:sldId id="272" r:id="rId23"/>
     <p:sldId id="273" r:id="rId24"/>
     <p:sldId id="274" r:id="rId25"/>
-    <p:sldId id="275" r:id="rId26"/>
   </p:sldIdLst>
   <p:sldSz cx="12191695" cy="6858000" type="screen4x3"/>
   <p:notesSz cx="6858000" cy="9144000"/>
@@ -5770,7 +5769,7 @@
               </a:defRPr>
             </a:pPr>
             <a:r>
-              <a:t>Hackathon 60-Second Demo &amp; 20-Min Wow Factor</a:t>
+              <a:t>Live Deployment &amp; Repository Access</a:t>
             </a:r>
           </a:p>
         </p:txBody>
@@ -5805,7 +5804,7 @@
               </a:defRPr>
             </a:pPr>
             <a:r>
-              <a:t>Winning Presentation Techniques for Evaluation Panels</a:t>
+              <a:t>Antigravity AG 3D Capstone AI Mentor is Live in Production</a:t>
             </a:r>
           </a:p>
         </p:txBody>
@@ -5888,7 +5887,7 @@
               </a:defRPr>
             </a:pPr>
             <a:r>
-              <a:t>•  60-Second Judge Demo Script: Concise script highlighting input, processing pipeline, and results in &lt; 60s.</a:t>
+              <a:t>•  Live Production Web App: https://3hr-promptwars.vercel.app</a:t>
             </a:r>
           </a:p>
           <a:p>
@@ -5903,7 +5902,7 @@
               </a:defRPr>
             </a:pPr>
             <a:r>
-              <a:t>•  20-Minute Wow Factors: One-click PDF brief export, language switcher, or README.md generator.</a:t>
+              <a:t>•  GitHub Repository: https://github.com/ishansharma16012007-bot/3hr-promptwars</a:t>
             </a:r>
           </a:p>
           <a:p>
@@ -5918,7 +5917,22 @@
               </a:defRPr>
             </a:pPr>
             <a:r>
-              <a:t>•  Judge Questions Ready: Prepared answers for model accuracy, dataset fallbacks, and deployment scaling.</a:t>
+              <a:t>•  Localhost Engine: http://127.0.0.1:8000</a:t>
+            </a:r>
+          </a:p>
+          <a:p>
+            <a:pPr>
+              <a:spcAft>
+                <a:spcPts val="1200"/>
+              </a:spcAft>
+              <a:defRPr sz="1500">
+                <a:solidFill>
+                  <a:srgbClr val="FFFFFF"/>
+                </a:solidFill>
+              </a:defRPr>
+            </a:pPr>
+            <a:r>
+              <a:t>•  Built with FastAPI, Gemini 2.5 Flash, Tailwind CSS, 3D Glassmorphism, &amp; Vercel Serverless.</a:t>
             </a:r>
           </a:p>
         </p:txBody>
@@ -6178,265 +6192,6 @@
             </a:pPr>
             <a:r>
               <a:t>•  Judge Presentation Gaps: Inability to structure a crisp 60-second live demo script highlighting core AI.</a:t>
-            </a:r>
-          </a:p>
-        </p:txBody>
-      </p:sp>
-    </p:spTree>
-  </p:cSld>
-  <p:clrMapOvr>
-    <a:masterClrMapping/>
-  </p:clrMapOvr>
-</p:sld>
-</file>
-
-<file path=ppt/slides/slide20.xml><?xml version="1.0" encoding="utf-8"?>
-<p:sld xmlns:a="http://schemas.openxmlformats.org/drawingml/2006/main" xmlns:p="http://schemas.openxmlformats.org/presentationml/2006/main" xmlns:r="http://schemas.openxmlformats.org/officeDocument/2006/relationships">
-  <p:cSld>
-    <p:spTree>
-      <p:nvGrpSpPr>
-        <p:cNvPr id="1" name=""/>
-        <p:cNvGrpSpPr/>
-        <p:nvPr/>
-      </p:nvGrpSpPr>
-      <p:grpSpPr/>
-      <p:sp>
-        <p:nvSpPr>
-          <p:cNvPr id="2" name="Rectangle 1"/>
-          <p:cNvSpPr/>
-          <p:nvPr/>
-        </p:nvSpPr>
-        <p:spPr>
-          <a:xfrm>
-            <a:off x="0" y="0"/>
-            <a:ext cx="12191695" cy="6858000"/>
-          </a:xfrm>
-          <a:prstGeom prst="rect">
-            <a:avLst/>
-          </a:prstGeom>
-          <a:solidFill>
-            <a:srgbClr val="011711"/>
-          </a:solidFill>
-          <a:ln>
-            <a:noFill/>
-          </a:ln>
-        </p:spPr>
-        <p:style>
-          <a:lnRef idx="1">
-            <a:schemeClr val="accent1"/>
-          </a:lnRef>
-          <a:fillRef idx="3">
-            <a:schemeClr val="accent1"/>
-          </a:fillRef>
-          <a:effectRef idx="2">
-            <a:schemeClr val="accent1"/>
-          </a:effectRef>
-          <a:fontRef idx="minor">
-            <a:schemeClr val="lt1"/>
-          </a:fontRef>
-        </p:style>
-        <p:txBody>
-          <a:bodyPr rtlCol="0" anchor="ctr"/>
-          <a:lstStyle/>
-          <a:p>
-            <a:pPr algn="ctr"/>
-          </a:p>
-        </p:txBody>
-      </p:sp>
-      <p:sp>
-        <p:nvSpPr>
-          <p:cNvPr id="3" name="TextBox 2"/>
-          <p:cNvSpPr txBox="1"/>
-          <p:nvPr/>
-        </p:nvSpPr>
-        <p:spPr>
-          <a:xfrm>
-            <a:off x="731520" y="457200"/>
-            <a:ext cx="10698480" cy="731520"/>
-          </a:xfrm>
-          <a:prstGeom prst="rect">
-            <a:avLst/>
-          </a:prstGeom>
-          <a:noFill/>
-        </p:spPr>
-        <p:txBody>
-          <a:bodyPr wrap="square">
-            <a:spAutoFit/>
-          </a:bodyPr>
-          <a:lstStyle/>
-          <a:p>
-            <a:pPr>
-              <a:defRPr sz="2800" b="1">
-                <a:solidFill>
-                  <a:srgbClr val="34D399"/>
-                </a:solidFill>
-              </a:defRPr>
-            </a:pPr>
-            <a:r>
-              <a:t>Live Deployment &amp; Repository Access</a:t>
-            </a:r>
-          </a:p>
-        </p:txBody>
-      </p:sp>
-      <p:sp>
-        <p:nvSpPr>
-          <p:cNvPr id="4" name="TextBox 3"/>
-          <p:cNvSpPr txBox="1"/>
-          <p:nvPr/>
-        </p:nvSpPr>
-        <p:spPr>
-          <a:xfrm>
-            <a:off x="731520" y="1097280"/>
-            <a:ext cx="10698480" cy="457200"/>
-          </a:xfrm>
-          <a:prstGeom prst="rect">
-            <a:avLst/>
-          </a:prstGeom>
-          <a:noFill/>
-        </p:spPr>
-        <p:txBody>
-          <a:bodyPr wrap="none">
-            <a:spAutoFit/>
-          </a:bodyPr>
-          <a:lstStyle/>
-          <a:p>
-            <a:pPr>
-              <a:defRPr sz="1600" b="1">
-                <a:solidFill>
-                  <a:srgbClr val="FBBF24"/>
-                </a:solidFill>
-              </a:defRPr>
-            </a:pPr>
-            <a:r>
-              <a:t>Antigravity AG 3D Capstone AI Mentor is Live in Production</a:t>
-            </a:r>
-          </a:p>
-        </p:txBody>
-      </p:sp>
-      <p:sp>
-        <p:nvSpPr>
-          <p:cNvPr id="5" name="Rounded Rectangle 4"/>
-          <p:cNvSpPr/>
-          <p:nvPr/>
-        </p:nvSpPr>
-        <p:spPr>
-          <a:xfrm>
-            <a:off x="731520" y="1737360"/>
-            <a:ext cx="10698480" cy="3931920"/>
-          </a:xfrm>
-          <a:prstGeom prst="roundRect">
-            <a:avLst/>
-          </a:prstGeom>
-          <a:solidFill>
-            <a:srgbClr val="04251C"/>
-          </a:solidFill>
-          <a:ln>
-            <a:solidFill>
-              <a:srgbClr val="10B981"/>
-            </a:solidFill>
-          </a:ln>
-        </p:spPr>
-        <p:style>
-          <a:lnRef idx="1">
-            <a:schemeClr val="accent1"/>
-          </a:lnRef>
-          <a:fillRef idx="3">
-            <a:schemeClr val="accent1"/>
-          </a:fillRef>
-          <a:effectRef idx="2">
-            <a:schemeClr val="accent1"/>
-          </a:effectRef>
-          <a:fontRef idx="minor">
-            <a:schemeClr val="lt1"/>
-          </a:fontRef>
-        </p:style>
-        <p:txBody>
-          <a:bodyPr rtlCol="0" anchor="ctr"/>
-          <a:lstStyle/>
-          <a:p>
-            <a:pPr algn="ctr"/>
-          </a:p>
-        </p:txBody>
-      </p:sp>
-      <p:sp>
-        <p:nvSpPr>
-          <p:cNvPr id="6" name="TextBox 5"/>
-          <p:cNvSpPr txBox="1"/>
-          <p:nvPr/>
-        </p:nvSpPr>
-        <p:spPr>
-          <a:xfrm>
-            <a:off x="1005840" y="1920240"/>
-            <a:ext cx="10149840" cy="3566160"/>
-          </a:xfrm>
-          <a:prstGeom prst="rect">
-            <a:avLst/>
-          </a:prstGeom>
-          <a:noFill/>
-        </p:spPr>
-        <p:txBody>
-          <a:bodyPr wrap="square">
-            <a:spAutoFit/>
-          </a:bodyPr>
-          <a:lstStyle/>
-          <a:p>
-            <a:pPr>
-              <a:spcAft>
-                <a:spcPts val="1200"/>
-              </a:spcAft>
-              <a:defRPr sz="1500">
-                <a:solidFill>
-                  <a:srgbClr val="FFFFFF"/>
-                </a:solidFill>
-              </a:defRPr>
-            </a:pPr>
-            <a:r>
-              <a:t>•  Live Production Web App: https://3hr-promptwars.vercel.app</a:t>
-            </a:r>
-          </a:p>
-          <a:p>
-            <a:pPr>
-              <a:spcAft>
-                <a:spcPts val="1200"/>
-              </a:spcAft>
-              <a:defRPr sz="1500">
-                <a:solidFill>
-                  <a:srgbClr val="FFFFFF"/>
-                </a:solidFill>
-              </a:defRPr>
-            </a:pPr>
-            <a:r>
-              <a:t>•  GitHub Repository: https://github.com/ishansharma16012007-bot/3hr-promptwars</a:t>
-            </a:r>
-          </a:p>
-          <a:p>
-            <a:pPr>
-              <a:spcAft>
-                <a:spcPts val="1200"/>
-              </a:spcAft>
-              <a:defRPr sz="1500">
-                <a:solidFill>
-                  <a:srgbClr val="FFFFFF"/>
-                </a:solidFill>
-              </a:defRPr>
-            </a:pPr>
-            <a:r>
-              <a:t>•  Localhost Engine: http://127.0.0.1:8000</a:t>
-            </a:r>
-          </a:p>
-          <a:p>
-            <a:pPr>
-              <a:spcAft>
-                <a:spcPts val="1200"/>
-              </a:spcAft>
-              <a:defRPr sz="1500">
-                <a:solidFill>
-                  <a:srgbClr val="FFFFFF"/>
-                </a:solidFill>
-              </a:defRPr>
-            </a:pPr>
-            <a:r>
-              <a:t>•  Built with FastAPI, Gemini 2.5 Flash, Tailwind CSS, 3D Glassmorphism, &amp; Vercel Serverless.</a:t>
             </a:r>
           </a:p>
         </p:txBody>

</xml_diff>